<commit_message>
Exercise #3: community indicators, strategies step and reordered functions
Replace CCVI with the Chicago Health Atlas indicators used in Exercise #2
(community_areas_ses). Step 3 maps every indicator in a dropdown with L lines
and stations colored by the change in weekday boardings, plots boardings by
indicator quintile and summarizes population, stations and boardings by
quintile. Step 4 asks students to choose focus community areas, diagnose
barriers with Walker's seven demands and trip phases, and propose strategies,
supported by a sortable community area table. Functions are defined before
first use in the new step order, and the dataprep script and slide template
(now 8 slides, with a strategy table) are updated to match.

Co-Authored-By: Claude Opus 5.5 <noreply@anthropic.com>
Claude-Session: https://claude.ai/code/session_0177Y5z9RX4JsnuEztNAPDiw
</commit_message>
<xml_diff>
--- a/2027/GEO330_Fall_Quarter/exercises/Exercise_03/slides/Exercise03_Template.pptx
+++ b/2027/GEO330_Fall_Quarter/exercises/Exercise_03/slides/Exercise03_Template.pptx
@@ -10,6 +10,8 @@
     <p:sldId id="276" r:id="rId6"/>
     <p:sldId id="274" r:id="rId8"/>
     <p:sldId id="275" r:id="rId9"/>
+    <p:sldId id="277" r:id="rId10"/>
+    <p:sldId id="279" r:id="rId11"/>
     <p:sldId id="278" r:id="rId12"/>
   </p:sldIdLst>
   <p:sldSz cx="12192000" cy="6858000"/>
@@ -3610,21 +3612,21 @@
             </a:pPr>
             <a:r>
               <a:rPr lang="en-US" sz="3400" dirty="0"/>
-              <a:t>COVID-19 VULNERABILITY (CCVI)</a:t>
+              <a:t>COVID-19 CASES</a:t>
             </a:r>
             <a:br>
               <a:rPr lang="en-US" sz="3400" dirty="0"/>
             </a:br>
             <a:r>
               <a:rPr lang="en-US" sz="3400" dirty="0"/>
-              <a:t>City of Chicago Community Areas</a:t>
+              <a:t>City of Chicago</a:t>
             </a:r>
             <a:br>
               <a:rPr lang="en-US" sz="3400" dirty="0"/>
             </a:br>
             <a:r>
               <a:rPr lang="en-US" sz="3400" dirty="0"/>
-              <a:t>L Lines and Stations</a:t>
+              <a:t>2020-2024</a:t>
             </a:r>
           </a:p>
         </p:txBody>
@@ -3661,7 +3663,7 @@
               <a:rPr lang="en-US" sz="1600" i="1" dirty="0">
                 <a:latin typeface="Abadi Extra Light" panose="020B0604020202020204" pitchFamily="34" charset="0"/>
               </a:rPr>
-              <a:t>Describe the geographic distribution of COVID-19 vulnerability across Chicago. Which parts of the city have the highest and lowest CCVI scores? Use the dropdown list to compare the CCVI category with individual ranks, such as socioeconomic status and essential workers. Which components appear to drive vulnerability in different parts of the city? How well do L lines and stations serve the most vulnerable community areas?</a:t>
+              <a:t>Identify the major waves of the COVID-19 pandemic in Chicago. When were cases highest, and how did the waves differ in size and timing? Keep these waves in mind as you compare them with L ridership in the slides that follow.</a:t>
             </a:r>
           </a:p>
         </p:txBody>
@@ -3698,7 +3700,7 @@
               <a:rPr lang="en-US" sz="1400" i="1" dirty="0">
                 <a:latin typeface="Abadi Extra Light" panose="020B0604020202020204" pitchFamily="34" charset="0"/>
               </a:rPr>
-              <a:t>Data sources: City of Chicago Data Portal (CCVI; Community Areas); RTAMS (CTA Rail Lines and Stations).</a:t>
+              <a:t>Data sources: City of Chicago Data Portal (COVID-19 Daily Cases, Deaths, and Hospitalizations).</a:t>
             </a:r>
             <a:endParaRPr lang="en-US" sz="1400" i="1" cap="none" dirty="0">
               <a:latin typeface="Abadi Extra Light" panose="020B0604020202020204" pitchFamily="34" charset="0"/>
@@ -3744,7 +3746,7 @@
             <a:pPr algn="ctr"/>
             <a:r>
               <a:rPr lang="en-US" dirty="0"/>
-              <a:t>Insert custom CCVI map (Figure 1)</a:t>
+              <a:t>Insert custom COVID-19 cases plot (Figure 1)</a:t>
             </a:r>
             <a:br>
               <a:rPr lang="en-US" dirty="0"/>
@@ -3876,21 +3878,21 @@
             </a:pPr>
             <a:r>
               <a:rPr lang="en-US" sz="3400" dirty="0"/>
-              <a:t>COVID-19 CASES</a:t>
+              <a:t>CTA L RIDERSHIP</a:t>
             </a:r>
             <a:br>
               <a:rPr lang="en-US" sz="3400" dirty="0"/>
             </a:br>
             <a:r>
               <a:rPr lang="en-US" sz="3400" dirty="0"/>
-              <a:t>City of Chicago</a:t>
+              <a:t>Weekday Boardings</a:t>
             </a:r>
             <a:br>
               <a:rPr lang="en-US" sz="3400" dirty="0"/>
             </a:br>
             <a:r>
               <a:rPr lang="en-US" sz="3400" dirty="0"/>
-              <a:t>2020-2024</a:t>
+              <a:t>1999-2026</a:t>
             </a:r>
           </a:p>
         </p:txBody>
@@ -3927,7 +3929,7 @@
               <a:rPr lang="en-US" sz="1600" i="1" dirty="0">
                 <a:latin typeface="Abadi Extra Light" panose="020B0604020202020204" pitchFamily="34" charset="0"/>
               </a:rPr>
-              <a:t>Compare COVID-19 cases with the ridership plots in slide 2 and identify the major waves of the pandemic. Did ridership dip during each wave, or did it continue to recover regardless of case counts? What does this suggest about the role of health risk compared with other factors, such as remote work, in shaping transit ridership?</a:t>
+              <a:t>Describe long-term trends in L ridership. How did ridership change before the pandemic? How sharply did it fall in spring 2020, and how much has it recovered? Did ridership dip during each COVID-19 wave (slide 1)? Consider how remote work, service levels, perceptions of safety and changes in mode choice might explain the patterns you observe.</a:t>
             </a:r>
           </a:p>
         </p:txBody>
@@ -3964,7 +3966,7 @@
               <a:rPr lang="en-US" sz="1400" i="1" dirty="0">
                 <a:latin typeface="Abadi Extra Light" panose="020B0604020202020204" pitchFamily="34" charset="0"/>
               </a:rPr>
-              <a:t>Data sources: City of Chicago Data Portal (COVID-19 Daily Cases, Deaths, and Hospitalizations); RTAMS (CTA Ridership).</a:t>
+              <a:t>Data sources: RTAMS (CTA Ridership); City of Chicago Data Portal (CTA Daily Boarding Totals).</a:t>
             </a:r>
             <a:endParaRPr lang="en-US" sz="1400" i="1" cap="none" dirty="0">
               <a:latin typeface="Abadi Extra Light" panose="020B0604020202020204" pitchFamily="34" charset="0"/>
@@ -3981,7 +3983,7 @@
         <p:spPr>
           <a:xfrm>
             <a:off x="6735536" y="1698171"/>
-            <a:ext cx="4302578" cy="3788229"/>
+            <a:ext cx="4302578" cy="1799114"/>
           </a:xfrm>
           <a:prstGeom prst="roundRect">
             <a:avLst/>
@@ -4010,14 +4012,78 @@
             <a:pPr algn="ctr"/>
             <a:r>
               <a:rPr lang="en-US" dirty="0"/>
-              <a:t>Insert custom COVID-19 cases plot (Figure 4)</a:t>
+              <a:t>Insert monthly L boardings plot</a:t>
             </a:r>
             <a:br>
               <a:rPr lang="en-US" dirty="0"/>
             </a:br>
             <a:r>
               <a:rPr lang="en-US" dirty="0"/>
-              <a:t>created in step #3 of exercise.</a:t>
+              <a:t>(Figure 2)</a:t>
+            </a:r>
+            <a:br>
+              <a:rPr lang="en-US" dirty="0"/>
+            </a:br>
+            <a:r>
+              <a:rPr lang="en-US" dirty="0"/>
+              <a:t>available in step #2 of exercise.</a:t>
+            </a:r>
+          </a:p>
+        </p:txBody>
+      </p:sp>
+      <p:sp>
+        <p:nvSpPr>
+          <p:cNvPr id="4" name="Placeholder 2"/>
+          <p:cNvSpPr/>
+          <p:nvPr/>
+        </p:nvSpPr>
+        <p:spPr>
+          <a:xfrm>
+            <a:off x="6735536" y="3687285"/>
+            <a:ext cx="4302578" cy="1799114"/>
+          </a:xfrm>
+          <a:prstGeom prst="roundRect">
+            <a:avLst/>
+          </a:prstGeom>
+        </p:spPr>
+        <p:style>
+          <a:lnRef idx="2">
+            <a:schemeClr val="accent1">
+              <a:shade val="15000"/>
+            </a:schemeClr>
+          </a:lnRef>
+          <a:fillRef idx="1">
+            <a:schemeClr val="accent1"/>
+          </a:fillRef>
+          <a:effectRef idx="0">
+            <a:schemeClr val="accent1"/>
+          </a:effectRef>
+          <a:fontRef idx="minor">
+            <a:schemeClr val="lt1"/>
+          </a:fontRef>
+        </p:style>
+        <p:txBody>
+          <a:bodyPr rtlCol="0" anchor="ctr"/>
+          <a:lstStyle/>
+          <a:p>
+            <a:pPr algn="ctr"/>
+            <a:r>
+              <a:rPr lang="en-US" dirty="0"/>
+              <a:t>Insert daily L boardings plot</a:t>
+            </a:r>
+            <a:br>
+              <a:rPr lang="en-US" dirty="0"/>
+            </a:br>
+            <a:r>
+              <a:rPr lang="en-US" dirty="0"/>
+              <a:t>(Figure 3)</a:t>
+            </a:r>
+            <a:br>
+              <a:rPr lang="en-US" dirty="0"/>
+            </a:br>
+            <a:r>
+              <a:rPr lang="en-US" dirty="0"/>
+              <a:t>available in step #2 of exercise.</a:t>
             </a:r>
           </a:p>
         </p:txBody>
@@ -4071,7 +4137,7 @@
           <a:p>
             <a:fld id="{C3DB2ADC-AF19-4574-8C10-79B5B04FCA27}" type="slidenum">
               <a:rPr lang="en-US" sz="1050"/>
-              <a:t>3</a:t>
+              <a:t>2</a:t>
             </a:fld>
             <a:endParaRPr lang="en-US" sz="1050"/>
           </a:p>
@@ -4080,7 +4146,7 @@
     </p:spTree>
     <p:extLst>
       <p:ext uri="{BB962C8B-B14F-4D97-AF65-F5344CB8AC3E}">
-        <p14:creationId xmlns:p14="http://schemas.microsoft.com/office/powerpoint/2010/main" val="3196567085"/>
+        <p14:creationId xmlns:p14="http://schemas.microsoft.com/office/powerpoint/2010/main" val="3196567086"/>
       </p:ext>
     </p:extLst>
   </p:cSld>
@@ -4142,14 +4208,14 @@
             </a:pPr>
             <a:r>
               <a:rPr lang="en-US" sz="3400" dirty="0"/>
-              <a:t>CTA L RIDERSHIP</a:t>
+              <a:t>L RIDERSHIP BY LINE</a:t>
             </a:r>
             <a:br>
               <a:rPr lang="en-US" sz="3400" dirty="0"/>
             </a:br>
             <a:r>
               <a:rPr lang="en-US" sz="3400" dirty="0"/>
-              <a:t>Weekday Boardings</a:t>
+              <a:t>[INSERT LINE] and [INSERT LINE] Lines</a:t>
             </a:r>
             <a:br>
               <a:rPr lang="en-US" sz="3400" dirty="0"/>
@@ -4193,7 +4259,7 @@
               <a:rPr lang="en-US" sz="1600" i="1" dirty="0">
                 <a:latin typeface="Abadi Extra Light" panose="020B0604020202020204" pitchFamily="34" charset="0"/>
               </a:rPr>
-              <a:t>Describe long-term trends in L ridership (Figures 2 and 3). How did ridership change in the two decades before the pandemic? How sharply did ridership fall in spring 2020, and how much has it recovered since? Consider how factors such as remote work, service levels, perceptions of safety and changes in mode choice might explain the patterns you observe.</a:t>
+              <a:t>Compare ridership on the two lines you selected over time. How did each line's ridership change during and after the pandemic, and which has recovered more? Consider the neighborhoods and destinations each line serves (e.g., downtown, airports, universities, hospitals) and how the trips people make on each line may have changed.</a:t>
             </a:r>
           </a:p>
         </p:txBody>
@@ -4230,7 +4296,7 @@
               <a:rPr lang="en-US" sz="1400" i="1" dirty="0">
                 <a:latin typeface="Abadi Extra Light" panose="020B0604020202020204" pitchFamily="34" charset="0"/>
               </a:rPr>
-              <a:t>Data sources: RTAMS (CTA Ridership); City of Chicago Data Portal (CTA Daily Boarding Totals).</a:t>
+              <a:t>Data sources: RTAMS (CTA Ridership; Rail Stations).</a:t>
             </a:r>
             <a:endParaRPr lang="en-US" sz="1400" i="1" cap="none" dirty="0">
               <a:latin typeface="Abadi Extra Light" panose="020B0604020202020204" pitchFamily="34" charset="0"/>
@@ -4247,7 +4313,7 @@
         <p:spPr>
           <a:xfrm>
             <a:off x="6735536" y="1698171"/>
-            <a:ext cx="4302578" cy="1799114"/>
+            <a:ext cx="4302578" cy="3788229"/>
           </a:xfrm>
           <a:prstGeom prst="roundRect">
             <a:avLst/>
@@ -4276,78 +4342,14 @@
             <a:pPr algn="ctr"/>
             <a:r>
               <a:rPr lang="en-US" dirty="0"/>
-              <a:t>Insert monthly L boardings plot</a:t>
+              <a:t>Insert custom ridership plot for selected lines (Figure 4)</a:t>
             </a:r>
             <a:br>
               <a:rPr lang="en-US" dirty="0"/>
             </a:br>
             <a:r>
               <a:rPr lang="en-US" dirty="0"/>
-              <a:t>(Figure 2)</a:t>
-            </a:r>
-            <a:br>
-              <a:rPr lang="en-US" dirty="0"/>
-            </a:br>
-            <a:r>
-              <a:rPr lang="en-US" dirty="0"/>
-              <a:t>available in step #3 of exercise.</a:t>
-            </a:r>
-          </a:p>
-        </p:txBody>
-      </p:sp>
-      <p:sp>
-        <p:nvSpPr>
-          <p:cNvPr id="4" name="Placeholder 2"/>
-          <p:cNvSpPr/>
-          <p:nvPr/>
-        </p:nvSpPr>
-        <p:spPr>
-          <a:xfrm>
-            <a:off x="6735536" y="3687285"/>
-            <a:ext cx="4302578" cy="1799114"/>
-          </a:xfrm>
-          <a:prstGeom prst="roundRect">
-            <a:avLst/>
-          </a:prstGeom>
-        </p:spPr>
-        <p:style>
-          <a:lnRef idx="2">
-            <a:schemeClr val="accent1">
-              <a:shade val="15000"/>
-            </a:schemeClr>
-          </a:lnRef>
-          <a:fillRef idx="1">
-            <a:schemeClr val="accent1"/>
-          </a:fillRef>
-          <a:effectRef idx="0">
-            <a:schemeClr val="accent1"/>
-          </a:effectRef>
-          <a:fontRef idx="minor">
-            <a:schemeClr val="lt1"/>
-          </a:fontRef>
-        </p:style>
-        <p:txBody>
-          <a:bodyPr rtlCol="0" anchor="ctr"/>
-          <a:lstStyle/>
-          <a:p>
-            <a:pPr algn="ctr"/>
-            <a:r>
-              <a:rPr lang="en-US" dirty="0"/>
-              <a:t>Insert daily L boardings plot</a:t>
-            </a:r>
-            <a:br>
-              <a:rPr lang="en-US" dirty="0"/>
-            </a:br>
-            <a:r>
-              <a:rPr lang="en-US" dirty="0"/>
-              <a:t>(Figure 3)</a:t>
-            </a:r>
-            <a:br>
-              <a:rPr lang="en-US" dirty="0"/>
-            </a:br>
-            <a:r>
-              <a:rPr lang="en-US" dirty="0"/>
-              <a:t>available in step #3 of exercise.</a:t>
+              <a:t>created in step #2 of exercise.</a:t>
             </a:r>
           </a:p>
         </p:txBody>
@@ -4401,7 +4403,7 @@
           <a:p>
             <a:fld id="{C3DB2ADC-AF19-4574-8C10-79B5B04FCA27}" type="slidenum">
               <a:rPr lang="en-US" sz="1050"/>
-              <a:t>2</a:t>
+              <a:t>3</a:t>
             </a:fld>
             <a:endParaRPr lang="en-US" sz="1050"/>
           </a:p>
@@ -4410,7 +4412,7 @@
     </p:spTree>
     <p:extLst>
       <p:ext uri="{BB962C8B-B14F-4D97-AF65-F5344CB8AC3E}">
-        <p14:creationId xmlns:p14="http://schemas.microsoft.com/office/powerpoint/2010/main" val="3196567086"/>
+        <p14:creationId xmlns:p14="http://schemas.microsoft.com/office/powerpoint/2010/main" val="3196567085"/>
       </p:ext>
     </p:extLst>
   </p:cSld>
@@ -4472,21 +4474,21 @@
             </a:pPr>
             <a:r>
               <a:rPr lang="en-US" sz="3400" dirty="0"/>
-              <a:t>L RIDERSHIP BY CCVI CATEGORY</a:t>
+              <a:t>CHANGE IN RIDERSHIP BY STATION</a:t>
             </a:r>
             <a:br>
               <a:rPr lang="en-US" sz="3400" dirty="0"/>
             </a:br>
             <a:r>
               <a:rPr lang="en-US" sz="3400" dirty="0"/>
-              <a:t>Weekday Boardings</a:t>
+              <a:t>[INSERT LINE] and [INSERT LINE] Lines</a:t>
             </a:r>
             <a:br>
               <a:rPr lang="en-US" sz="3400" dirty="0"/>
             </a:br>
             <a:r>
               <a:rPr lang="en-US" sz="3400" dirty="0"/>
-              <a:t>1999-2026</a:t>
+              <a:t>[MONTH] 2019 to [MONTH YEAR]</a:t>
             </a:r>
           </a:p>
         </p:txBody>
@@ -4523,7 +4525,7 @@
               <a:rPr lang="en-US" sz="1600" i="1" dirty="0">
                 <a:latin typeface="Abadi Extra Light" panose="020B0604020202020204" pitchFamily="34" charset="0"/>
               </a:rPr>
-              <a:t>Describe how ridership trends differ by CCVI category. Which category accounted for the most boardings before the pandemic? Did ridership fall more steeply, or recover more quickly, at stations in more vulnerable communities? Consider who rides transit in these communities, such as essential workers who could not work from home, and what the differences suggest about transit equity.</a:t>
+              <a:t>Describe the geographic pattern of ridership change along the two lines. Which stations have recovered the most and least? Consider the land uses around each station, such as downtown offices, residential neighborhoods, universities and major destinations, and how the pandemic may have changed travel to each.</a:t>
             </a:r>
           </a:p>
         </p:txBody>
@@ -4560,7 +4562,7 @@
               <a:rPr lang="en-US" sz="1400" i="1" dirty="0">
                 <a:latin typeface="Abadi Extra Light" panose="020B0604020202020204" pitchFamily="34" charset="0"/>
               </a:rPr>
-              <a:t>Data sources: RTAMS (CTA Ridership; CTA Rail Stations); City of Chicago Data Portal (CCVI).</a:t>
+              <a:t>Data sources: RTAMS (CTA Ridership; Rail Lines and Stations).</a:t>
             </a:r>
             <a:endParaRPr lang="en-US" sz="1400" i="1" cap="none" dirty="0">
               <a:latin typeface="Abadi Extra Light" panose="020B0604020202020204" pitchFamily="34" charset="0"/>
@@ -4606,14 +4608,14 @@
             <a:pPr algn="ctr"/>
             <a:r>
               <a:rPr lang="en-US" dirty="0"/>
-              <a:t>Insert ridership by CCVI category plot (Figure 5)</a:t>
+              <a:t>Insert custom station ridership change map (Figure 5)</a:t>
             </a:r>
             <a:br>
               <a:rPr lang="en-US" dirty="0"/>
             </a:br>
             <a:r>
               <a:rPr lang="en-US" dirty="0"/>
-              <a:t>available in step #4 of exercise.</a:t>
+              <a:t>created in step #2 of exercise.</a:t>
             </a:r>
           </a:p>
         </p:txBody>
@@ -4738,21 +4740,21 @@
             </a:pPr>
             <a:r>
               <a:rPr lang="en-US" sz="3400" dirty="0"/>
-              <a:t>L RIDERSHIP BY LINE</a:t>
+              <a:t>COMMUNITY INDICATOR MAP</a:t>
             </a:r>
             <a:br>
               <a:rPr lang="en-US" sz="3400" dirty="0"/>
             </a:br>
             <a:r>
               <a:rPr lang="en-US" sz="3400" dirty="0"/>
-              <a:t>[INSERT LINE] and [INSERT LINE] Lines</a:t>
+              <a:t>[INSERT INDICATOR]</a:t>
             </a:r>
             <a:br>
               <a:rPr lang="en-US" sz="3400" dirty="0"/>
             </a:br>
             <a:r>
               <a:rPr lang="en-US" sz="3400" dirty="0"/>
-              <a:t>1999-2026</a:t>
+              <a:t>[INDICATOR PERIOD]</a:t>
             </a:r>
           </a:p>
         </p:txBody>
@@ -4789,7 +4791,7 @@
               <a:rPr lang="en-US" sz="1600" i="1" dirty="0">
                 <a:latin typeface="Abadi Extra Light" panose="020B0604020202020204" pitchFamily="34" charset="0"/>
               </a:rPr>
-              <a:t>Compare ridership on the two lines you selected over time. How did each line's ridership change during and after the pandemic? Consider the neighborhoods and destinations each line serves (e.g., downtown, airports, universities) and the CCVI categories of the community areas along each line.</a:t>
+              <a:t>Describe any relationship you see (or don't see) between the indicator, the location of L lines and stations, and the change in ridership at each station. Which parts of the city have the least advantaged conditions, and how well does the L serve them? Have stations in less advantaged communities recovered more or less than others?</a:t>
             </a:r>
           </a:p>
         </p:txBody>
@@ -4826,7 +4828,7 @@
               <a:rPr lang="en-US" sz="1400" i="1" dirty="0">
                 <a:latin typeface="Abadi Extra Light" panose="020B0604020202020204" pitchFamily="34" charset="0"/>
               </a:rPr>
-              <a:t>Data sources: RTAMS (CTA Ridership; CTA Rail Stations); City of Chicago Data Portal (CCVI).</a:t>
+              <a:t>Data sources: Chicago Health Atlas; RTAMS (CTA Ridership; Rail Lines and Stations).</a:t>
             </a:r>
             <a:endParaRPr lang="en-US" sz="1400" i="1" cap="none" dirty="0">
               <a:latin typeface="Abadi Extra Light" panose="020B0604020202020204" pitchFamily="34" charset="0"/>
@@ -4872,14 +4874,14 @@
             <a:pPr algn="ctr"/>
             <a:r>
               <a:rPr lang="en-US" dirty="0"/>
-              <a:t>Insert custom ridership plot for selected lines (Figure 6)</a:t>
+              <a:t>Insert custom community indicator map with L stations (Figure 6)</a:t>
             </a:r>
             <a:br>
               <a:rPr lang="en-US" dirty="0"/>
             </a:br>
             <a:r>
               <a:rPr lang="en-US" dirty="0"/>
-              <a:t>created in step #4 of exercise.</a:t>
+              <a:t>created in step #3 of exercise.</a:t>
             </a:r>
           </a:p>
         </p:txBody>
@@ -4943,6 +4945,599 @@
     <p:extLst>
       <p:ext uri="{BB962C8B-B14F-4D97-AF65-F5344CB8AC3E}">
         <p14:creationId xmlns:p14="http://schemas.microsoft.com/office/powerpoint/2010/main" val="3196567088"/>
+      </p:ext>
+    </p:extLst>
+  </p:cSld>
+  <p:clrMapOvr>
+    <a:masterClrMapping/>
+  </p:clrMapOvr>
+</p:sld>
+</file>
+
+<file path=ppt/slides/slide6.xml><?xml version="1.0" encoding="utf-8"?>
+<p:sld xmlns:a="http://schemas.openxmlformats.org/drawingml/2006/main" xmlns:r="http://schemas.openxmlformats.org/officeDocument/2006/relationships" xmlns:p="http://schemas.openxmlformats.org/presentationml/2006/main">
+  <p:cSld>
+    <p:spTree>
+      <p:nvGrpSpPr>
+        <p:cNvPr id="1" name=""/>
+        <p:cNvGrpSpPr/>
+        <p:nvPr/>
+      </p:nvGrpSpPr>
+      <p:grpSpPr>
+        <a:xfrm>
+          <a:off x="0" y="0"/>
+          <a:ext cx="0" cy="0"/>
+          <a:chOff x="0" y="0"/>
+          <a:chExt cx="0" cy="0"/>
+        </a:xfrm>
+      </p:grpSpPr>
+      <p:sp>
+        <p:nvSpPr>
+          <p:cNvPr id="6" name="Title 5">
+            <a:extLst>
+              <a:ext uri="{FF2B5EF4-FFF2-40B4-BE49-F238E27FC236}">
+                <a16:creationId xmlns:a16="http://schemas.microsoft.com/office/drawing/2014/main" id="{77977495-7045-4BEB-B038-AC19B9064EC1}"/>
+              </a:ext>
+            </a:extLst>
+          </p:cNvPr>
+          <p:cNvSpPr>
+            <a:spLocks noGrp="1"/>
+          </p:cNvSpPr>
+          <p:nvPr>
+            <p:ph type="title"/>
+          </p:nvPr>
+        </p:nvSpPr>
+        <p:spPr>
+          <a:xfrm>
+            <a:off x="669852" y="870596"/>
+            <a:ext cx="5426148" cy="577205"/>
+          </a:xfrm>
+        </p:spPr>
+        <p:txBody>
+          <a:bodyPr vert="horz" lIns="91440" tIns="45720" rIns="91440" bIns="45720" rtlCol="0" anchor="t">
+            <a:normAutofit fontScale="90000"/>
+          </a:bodyPr>
+          <a:lstStyle/>
+          <a:p>
+            <a:pPr>
+              <a:lnSpc>
+                <a:spcPct val="90000"/>
+              </a:lnSpc>
+            </a:pPr>
+            <a:r>
+              <a:rPr lang="en-US" sz="3400" dirty="0"/>
+              <a:t>L RIDERSHIP BY QUINTILE</a:t>
+            </a:r>
+            <a:br>
+              <a:rPr lang="en-US" sz="3400" dirty="0"/>
+            </a:br>
+            <a:r>
+              <a:rPr lang="en-US" sz="3400" dirty="0"/>
+              <a:t>[INSERT INDICATOR]</a:t>
+            </a:r>
+            <a:br>
+              <a:rPr lang="en-US" sz="3400" dirty="0"/>
+            </a:br>
+            <a:r>
+              <a:rPr lang="en-US" sz="3400" dirty="0"/>
+              <a:t>1999-2026</a:t>
+            </a:r>
+          </a:p>
+        </p:txBody>
+      </p:sp>
+      <p:sp>
+        <p:nvSpPr>
+          <p:cNvPr id="11" name="TextBox 10">
+            <a:extLst>
+              <a:ext uri="{FF2B5EF4-FFF2-40B4-BE49-F238E27FC236}">
+                <a16:creationId xmlns:a16="http://schemas.microsoft.com/office/drawing/2014/main" id="{3E48FC44-1FA2-4F7A-0A80-59B4E81301D5}"/>
+              </a:ext>
+            </a:extLst>
+          </p:cNvPr>
+          <p:cNvSpPr txBox="1"/>
+          <p:nvPr/>
+        </p:nvSpPr>
+        <p:spPr>
+          <a:xfrm>
+            <a:off x="700331" y="2150000"/>
+            <a:ext cx="5700000" cy="3200000"/>
+          </a:xfrm>
+          <a:prstGeom prst="rect">
+            <a:avLst/>
+          </a:prstGeom>
+          <a:noFill/>
+        </p:spPr>
+        <p:txBody>
+          <a:bodyPr wrap="square">
+            <a:spAutoFit/>
+          </a:bodyPr>
+          <a:lstStyle/>
+          <a:p>
+            <a:r>
+              <a:rPr lang="en-US" sz="1600" i="1" dirty="0">
+                <a:latin typeface="Abadi Extra Light" panose="020B0604020202020204" pitchFamily="34" charset="0"/>
+              </a:rPr>
+              <a:t>Describe how ridership trends differ across quintile categories. Did ridership fall more steeply, or recover more quickly, in less advantaged communities? Using the table, compare each category's share of population with its share of L stations and boardings. What do the differences suggest about who relies on the L and about equitable access to rail transit?</a:t>
+            </a:r>
+          </a:p>
+        </p:txBody>
+      </p:sp>
+      <p:sp>
+        <p:nvSpPr>
+          <p:cNvPr id="12" name="TextBox 11">
+            <a:extLst>
+              <a:ext uri="{FF2B5EF4-FFF2-40B4-BE49-F238E27FC236}">
+                <a16:creationId xmlns:a16="http://schemas.microsoft.com/office/drawing/2014/main" id="{87D582C6-CEC0-AFAA-58EF-768E3AC494E0}"/>
+              </a:ext>
+            </a:extLst>
+          </p:cNvPr>
+          <p:cNvSpPr txBox="1"/>
+          <p:nvPr/>
+        </p:nvSpPr>
+        <p:spPr>
+          <a:xfrm>
+            <a:off x="700331" y="5580302"/>
+            <a:ext cx="5953561" cy="307777"/>
+          </a:xfrm>
+          <a:prstGeom prst="rect">
+            <a:avLst/>
+          </a:prstGeom>
+          <a:noFill/>
+        </p:spPr>
+        <p:txBody>
+          <a:bodyPr wrap="square">
+            <a:spAutoFit/>
+          </a:bodyPr>
+          <a:lstStyle/>
+          <a:p>
+            <a:r>
+              <a:rPr lang="en-US" sz="1400" i="1" dirty="0">
+                <a:latin typeface="Abadi Extra Light" panose="020B0604020202020204" pitchFamily="34" charset="0"/>
+              </a:rPr>
+              <a:t>Data sources: Chicago Health Atlas; RTAMS (CTA Ridership; Rail Lines and Stations).</a:t>
+            </a:r>
+            <a:endParaRPr lang="en-US" sz="1400" i="1" cap="none" dirty="0">
+              <a:latin typeface="Abadi Extra Light" panose="020B0604020202020204" pitchFamily="34" charset="0"/>
+            </a:endParaRPr>
+          </a:p>
+        </p:txBody>
+      </p:sp>
+      <p:sp>
+        <p:nvSpPr>
+          <p:cNvPr id="3" name="Placeholder 1"/>
+          <p:cNvSpPr/>
+          <p:nvPr/>
+        </p:nvSpPr>
+        <p:spPr>
+          <a:xfrm>
+            <a:off x="6735536" y="1698171"/>
+            <a:ext cx="4302578" cy="1799114"/>
+          </a:xfrm>
+          <a:prstGeom prst="roundRect">
+            <a:avLst/>
+          </a:prstGeom>
+        </p:spPr>
+        <p:style>
+          <a:lnRef idx="2">
+            <a:schemeClr val="accent1">
+              <a:shade val="15000"/>
+            </a:schemeClr>
+          </a:lnRef>
+          <a:fillRef idx="1">
+            <a:schemeClr val="accent1"/>
+          </a:fillRef>
+          <a:effectRef idx="0">
+            <a:schemeClr val="accent1"/>
+          </a:effectRef>
+          <a:fontRef idx="minor">
+            <a:schemeClr val="lt1"/>
+          </a:fontRef>
+        </p:style>
+        <p:txBody>
+          <a:bodyPr rtlCol="0" anchor="ctr"/>
+          <a:lstStyle/>
+          <a:p>
+            <a:pPr algn="ctr"/>
+            <a:r>
+              <a:rPr lang="en-US" dirty="0"/>
+              <a:t>Insert custom plot of weekday boardings by quintile (Figure 7)</a:t>
+            </a:r>
+            <a:br>
+              <a:rPr lang="en-US" dirty="0"/>
+            </a:br>
+            <a:r>
+              <a:rPr lang="en-US" dirty="0"/>
+              <a:t>created in step #3 of exercise.</a:t>
+            </a:r>
+          </a:p>
+        </p:txBody>
+      </p:sp>
+      <p:sp>
+        <p:nvSpPr>
+          <p:cNvPr id="4" name="Placeholder 2"/>
+          <p:cNvSpPr/>
+          <p:nvPr/>
+        </p:nvSpPr>
+        <p:spPr>
+          <a:xfrm>
+            <a:off x="6735536" y="3687285"/>
+            <a:ext cx="4302578" cy="1799114"/>
+          </a:xfrm>
+          <a:prstGeom prst="roundRect">
+            <a:avLst/>
+          </a:prstGeom>
+        </p:spPr>
+        <p:style>
+          <a:lnRef idx="2">
+            <a:schemeClr val="accent1">
+              <a:shade val="15000"/>
+            </a:schemeClr>
+          </a:lnRef>
+          <a:fillRef idx="1">
+            <a:schemeClr val="accent1"/>
+          </a:fillRef>
+          <a:effectRef idx="0">
+            <a:schemeClr val="accent1"/>
+          </a:effectRef>
+          <a:fontRef idx="minor">
+            <a:schemeClr val="lt1"/>
+          </a:fontRef>
+        </p:style>
+        <p:txBody>
+          <a:bodyPr rtlCol="0" anchor="ctr"/>
+          <a:lstStyle/>
+          <a:p>
+            <a:pPr algn="ctr"/>
+            <a:r>
+              <a:rPr lang="en-US" dirty="0"/>
+              <a:t>Insert custom summary table by quintile (Table 1)</a:t>
+            </a:r>
+            <a:br>
+              <a:rPr lang="en-US" dirty="0"/>
+            </a:br>
+            <a:r>
+              <a:rPr lang="en-US" dirty="0"/>
+              <a:t>created in step #3 of exercise.</a:t>
+            </a:r>
+          </a:p>
+        </p:txBody>
+      </p:sp>
+      <p:sp>
+        <p:nvSpPr>
+          <p:cNvPr id="20" name="Footer Placeholder 19"/>
+          <p:cNvSpPr>
+            <a:spLocks noGrp="1"/>
+          </p:cNvSpPr>
+          <p:nvPr>
+            <p:ph type="ftr" sz="quarter" idx="11"/>
+          </p:nvPr>
+        </p:nvSpPr>
+        <p:spPr>
+          <a:xfrm>
+            <a:off x="715383" y="6230000"/>
+            <a:ext cx="10095603" cy="365125"/>
+          </a:xfrm>
+        </p:spPr>
+        <p:txBody>
+          <a:bodyPr/>
+          <a:lstStyle/>
+          <a:p>
+            <a:r>
+              <a:rPr lang="en-US" sz="1050" dirty="0"/>
+              <a:t>Sustainable Urban Transportation Exercise #3  |  Autumn 2026  |  DePaul University  |  C. Scott Smith, PhD AICP</a:t>
+            </a:r>
+          </a:p>
+        </p:txBody>
+      </p:sp>
+      <p:sp>
+        <p:nvSpPr>
+          <p:cNvPr id="21" name="Slide Number Placeholder 20"/>
+          <p:cNvSpPr>
+            <a:spLocks noGrp="1"/>
+          </p:cNvSpPr>
+          <p:nvPr>
+            <p:ph type="sldNum" sz="quarter" idx="12"/>
+          </p:nvPr>
+        </p:nvSpPr>
+        <p:spPr>
+          <a:xfrm>
+            <a:off x="10810986" y="6230000"/>
+            <a:ext cx="672354" cy="365125"/>
+          </a:xfrm>
+        </p:spPr>
+        <p:txBody>
+          <a:bodyPr/>
+          <a:lstStyle/>
+          <a:p>
+            <a:fld id="{C3DB2ADC-AF19-4574-8C10-79B5B04FCA27}" type="slidenum">
+              <a:rPr lang="en-US" sz="1050"/>
+              <a:t>6</a:t>
+            </a:fld>
+            <a:endParaRPr lang="en-US" sz="1050"/>
+          </a:p>
+        </p:txBody>
+      </p:sp>
+    </p:spTree>
+    <p:extLst>
+      <p:ext uri="{BB962C8B-B14F-4D97-AF65-F5344CB8AC3E}">
+        <p14:creationId xmlns:p14="http://schemas.microsoft.com/office/powerpoint/2010/main" val="3196567089"/>
+      </p:ext>
+    </p:extLst>
+  </p:cSld>
+  <p:clrMapOvr>
+    <a:masterClrMapping/>
+  </p:clrMapOvr>
+</p:sld>
+</file>
+
+<file path=ppt/slides/slide7.xml><?xml version="1.0" encoding="utf-8"?>
+<p:sld xmlns:a="http://schemas.openxmlformats.org/drawingml/2006/main" xmlns:r="http://schemas.openxmlformats.org/officeDocument/2006/relationships" xmlns:p="http://schemas.openxmlformats.org/presentationml/2006/main">
+  <p:cSld>
+    <p:spTree>
+      <p:nvGrpSpPr>
+        <p:cNvPr id="1" name=""/>
+        <p:cNvGrpSpPr/>
+        <p:nvPr/>
+      </p:nvGrpSpPr>
+      <p:grpSpPr>
+        <a:xfrm>
+          <a:off x="0" y="0"/>
+          <a:ext cx="0" cy="0"/>
+          <a:chOff x="0" y="0"/>
+          <a:chExt cx="0" cy="0"/>
+        </a:xfrm>
+      </p:grpSpPr>
+      <p:sp>
+        <p:nvSpPr>
+          <p:cNvPr id="6" name="Title 5">
+            <a:extLst>
+              <a:ext uri="{FF2B5EF4-FFF2-40B4-BE49-F238E27FC236}">
+                <a16:creationId xmlns:a16="http://schemas.microsoft.com/office/drawing/2014/main" id="{77977495-7045-4BEB-B038-AC19B9064EC1}"/>
+              </a:ext>
+            </a:extLst>
+          </p:cNvPr>
+          <p:cNvSpPr>
+            <a:spLocks noGrp="1"/>
+          </p:cNvSpPr>
+          <p:nvPr>
+            <p:ph type="title"/>
+          </p:nvPr>
+        </p:nvSpPr>
+        <p:spPr>
+          <a:xfrm>
+            <a:off x="669852" y="870596"/>
+            <a:ext cx="5426148" cy="577205"/>
+          </a:xfrm>
+        </p:spPr>
+        <p:txBody>
+          <a:bodyPr vert="horz" lIns="91440" tIns="45720" rIns="91440" bIns="45720" rtlCol="0" anchor="t">
+            <a:normAutofit fontScale="90000"/>
+          </a:bodyPr>
+          <a:lstStyle/>
+          <a:p>
+            <a:pPr>
+              <a:lnSpc>
+                <a:spcPct val="90000"/>
+              </a:lnSpc>
+            </a:pPr>
+            <a:r>
+              <a:rPr lang="en-US" sz="3400" dirty="0"/>
+              <a:t>FOCUS COMMUNITY AREAS</a:t>
+            </a:r>
+            <a:br>
+              <a:rPr lang="en-US" sz="3400" dirty="0"/>
+            </a:br>
+            <a:r>
+              <a:rPr lang="en-US" sz="3400" dirty="0"/>
+              <a:t>[INSERT COMMUNITY AREAS]</a:t>
+            </a:r>
+            <a:br>
+              <a:rPr lang="en-US" sz="3400" dirty="0"/>
+            </a:br>
+            <a:r>
+              <a:rPr lang="en-US" sz="3400" dirty="0"/>
+              <a:t>City of Chicago</a:t>
+            </a:r>
+          </a:p>
+        </p:txBody>
+      </p:sp>
+      <p:sp>
+        <p:nvSpPr>
+          <p:cNvPr id="11" name="TextBox 10">
+            <a:extLst>
+              <a:ext uri="{FF2B5EF4-FFF2-40B4-BE49-F238E27FC236}">
+                <a16:creationId xmlns:a16="http://schemas.microsoft.com/office/drawing/2014/main" id="{3E48FC44-1FA2-4F7A-0A80-59B4E81301D5}"/>
+              </a:ext>
+            </a:extLst>
+          </p:cNvPr>
+          <p:cNvSpPr txBox="1"/>
+          <p:nvPr/>
+        </p:nvSpPr>
+        <p:spPr>
+          <a:xfrm>
+            <a:off x="700331" y="2150000"/>
+            <a:ext cx="5700000" cy="3200000"/>
+          </a:xfrm>
+          <a:prstGeom prst="rect">
+            <a:avLst/>
+          </a:prstGeom>
+          <a:noFill/>
+        </p:spPr>
+        <p:txBody>
+          <a:bodyPr wrap="square">
+            <a:spAutoFit/>
+          </a:bodyPr>
+          <a:lstStyle/>
+          <a:p>
+            <a:r>
+              <a:rPr lang="en-US" sz="1600" i="1" dirty="0">
+                <a:latin typeface="Abadi Extra Light" panose="020B0604020202020204" pitchFamily="34" charset="0"/>
+              </a:rPr>
+              <a:t>Describe your three focus community areas: one with less advantaged conditions where ridership has recovered slowly, one where ridership has recovered strongly, and one with few or no L stations. What do the indicators, station locations and changes in ridership tell you about each? Why did you choose it?</a:t>
+            </a:r>
+          </a:p>
+        </p:txBody>
+      </p:sp>
+      <p:sp>
+        <p:nvSpPr>
+          <p:cNvPr id="12" name="TextBox 11">
+            <a:extLst>
+              <a:ext uri="{FF2B5EF4-FFF2-40B4-BE49-F238E27FC236}">
+                <a16:creationId xmlns:a16="http://schemas.microsoft.com/office/drawing/2014/main" id="{87D582C6-CEC0-AFAA-58EF-768E3AC494E0}"/>
+              </a:ext>
+            </a:extLst>
+          </p:cNvPr>
+          <p:cNvSpPr txBox="1"/>
+          <p:nvPr/>
+        </p:nvSpPr>
+        <p:spPr>
+          <a:xfrm>
+            <a:off x="700331" y="5580302"/>
+            <a:ext cx="5953561" cy="307777"/>
+          </a:xfrm>
+          <a:prstGeom prst="rect">
+            <a:avLst/>
+          </a:prstGeom>
+          <a:noFill/>
+        </p:spPr>
+        <p:txBody>
+          <a:bodyPr wrap="square">
+            <a:spAutoFit/>
+          </a:bodyPr>
+          <a:lstStyle/>
+          <a:p>
+            <a:r>
+              <a:rPr lang="en-US" sz="1400" i="1" dirty="0">
+                <a:latin typeface="Abadi Extra Light" panose="020B0604020202020204" pitchFamily="34" charset="0"/>
+              </a:rPr>
+              <a:t>Data sources: Chicago Health Atlas; RTAMS (CTA Ridership; Rail Lines and Stations).</a:t>
+            </a:r>
+            <a:endParaRPr lang="en-US" sz="1400" i="1" cap="none" dirty="0">
+              <a:latin typeface="Abadi Extra Light" panose="020B0604020202020204" pitchFamily="34" charset="0"/>
+            </a:endParaRPr>
+          </a:p>
+        </p:txBody>
+      </p:sp>
+      <p:sp>
+        <p:nvSpPr>
+          <p:cNvPr id="3" name="Placeholder 1"/>
+          <p:cNvSpPr/>
+          <p:nvPr/>
+        </p:nvSpPr>
+        <p:spPr>
+          <a:xfrm>
+            <a:off x="6735536" y="1698171"/>
+            <a:ext cx="4302578" cy="3788229"/>
+          </a:xfrm>
+          <a:prstGeom prst="roundRect">
+            <a:avLst/>
+          </a:prstGeom>
+        </p:spPr>
+        <p:style>
+          <a:lnRef idx="2">
+            <a:schemeClr val="accent1">
+              <a:shade val="15000"/>
+            </a:schemeClr>
+          </a:lnRef>
+          <a:fillRef idx="1">
+            <a:schemeClr val="accent1"/>
+          </a:fillRef>
+          <a:effectRef idx="0">
+            <a:schemeClr val="accent1"/>
+          </a:effectRef>
+          <a:fontRef idx="minor">
+            <a:schemeClr val="lt1"/>
+          </a:fontRef>
+        </p:style>
+        <p:txBody>
+          <a:bodyPr rtlCol="0" anchor="ctr"/>
+          <a:lstStyle/>
+          <a:p>
+            <a:pPr algn="ctr"/>
+            <a:r>
+              <a:rPr lang="en-US" dirty="0"/>
+              <a:t>Insert zoomed screenshot of community indicator map</a:t>
+            </a:r>
+            <a:br>
+              <a:rPr lang="en-US" dirty="0"/>
+            </a:br>
+            <a:r>
+              <a:rPr lang="en-US" dirty="0"/>
+              <a:t>(</a:t>
+            </a:r>
+            <a:r>
+              <a:rPr lang="en-US"/>
+              <a:t>Figure 6) showing focus community areas</a:t>
+            </a:r>
+            <a:br>
+              <a:rPr lang="en-US" dirty="0"/>
+            </a:br>
+            <a:r>
+              <a:rPr lang="en-US" dirty="0"/>
+              <a:t>created in step #4 of exercise.</a:t>
+            </a:r>
+          </a:p>
+        </p:txBody>
+      </p:sp>
+      <p:sp>
+        <p:nvSpPr>
+          <p:cNvPr id="20" name="Footer Placeholder 19"/>
+          <p:cNvSpPr>
+            <a:spLocks noGrp="1"/>
+          </p:cNvSpPr>
+          <p:nvPr>
+            <p:ph type="ftr" sz="quarter" idx="11"/>
+          </p:nvPr>
+        </p:nvSpPr>
+        <p:spPr>
+          <a:xfrm>
+            <a:off x="715383" y="6230000"/>
+            <a:ext cx="10095603" cy="365125"/>
+          </a:xfrm>
+        </p:spPr>
+        <p:txBody>
+          <a:bodyPr/>
+          <a:lstStyle/>
+          <a:p>
+            <a:r>
+              <a:rPr lang="en-US" sz="1050" dirty="0"/>
+              <a:t>Sustainable Urban Transportation Exercise #3  |  Autumn 2026  |  DePaul University  |  C. Scott Smith, PhD AICP</a:t>
+            </a:r>
+          </a:p>
+        </p:txBody>
+      </p:sp>
+      <p:sp>
+        <p:nvSpPr>
+          <p:cNvPr id="21" name="Slide Number Placeholder 20"/>
+          <p:cNvSpPr>
+            <a:spLocks noGrp="1"/>
+          </p:cNvSpPr>
+          <p:nvPr>
+            <p:ph type="sldNum" sz="quarter" idx="12"/>
+          </p:nvPr>
+        </p:nvSpPr>
+        <p:spPr>
+          <a:xfrm>
+            <a:off x="10810986" y="6230000"/>
+            <a:ext cx="672354" cy="365125"/>
+          </a:xfrm>
+        </p:spPr>
+        <p:txBody>
+          <a:bodyPr/>
+          <a:lstStyle/>
+          <a:p>
+            <a:fld id="{C3DB2ADC-AF19-4574-8C10-79B5B04FCA27}" type="slidenum">
+              <a:rPr lang="en-US" sz="1050"/>
+              <a:t>7</a:t>
+            </a:fld>
+            <a:endParaRPr lang="en-US" sz="1050"/>
+          </a:p>
+        </p:txBody>
+      </p:sp>
+    </p:spTree>
+    <p:extLst>
+      <p:ext uri="{BB962C8B-B14F-4D97-AF65-F5344CB8AC3E}">
+        <p14:creationId xmlns:p14="http://schemas.microsoft.com/office/powerpoint/2010/main" val="3196567091"/>
       </p:ext>
     </p:extLst>
   </p:cSld>
@@ -5004,21 +5599,21 @@
             </a:pPr>
             <a:r>
               <a:rPr lang="en-US" sz="3400" dirty="0"/>
-              <a:t>CHANGE IN RIDERSHIP BY STATION</a:t>
+              <a:t>STRATEGIES FOR IMPROVING RIDERSHIP</a:t>
             </a:r>
             <a:br>
               <a:rPr lang="en-US" sz="3400" dirty="0"/>
             </a:br>
             <a:r>
               <a:rPr lang="en-US" sz="3400" dirty="0"/>
-              <a:t>[INSERT LINE] and [INSERT LINE] Lines</a:t>
+              <a:t>Focus Community Areas and Citywide</a:t>
             </a:r>
             <a:br>
               <a:rPr lang="en-US" sz="3400" dirty="0"/>
             </a:br>
             <a:r>
               <a:rPr lang="en-US" sz="3400" dirty="0"/>
-              <a:t>[MONTH] 2019 to [MONTH YEAR]</a:t>
+              <a:t>City of Chicago</a:t>
             </a:r>
           </a:p>
         </p:txBody>
@@ -5055,7 +5650,7 @@
               <a:rPr lang="en-US" sz="1600" i="1" dirty="0">
                 <a:latin typeface="Abadi Extra Light" panose="020B0604020202020204" pitchFamily="34" charset="0"/>
               </a:rPr>
-              <a:t>Describe the geographic pattern of ridership change along the two lines. Which stations have recovered the most and least? Do stations in high-CCVI communities appear to have recovered differently from stations in low-CCVI communities, and what might explain the differences? Consider the land uses around each station, such as downtown offices, residential neighborhoods and major destinations.</a:t>
+              <a:t>Complete the table for your focus community areas using Walker's seven demands and seven phases of a trip. Then propose one citywide strategy that would do the most to increase L ridership in Chicago. Why did you choose it, who would benefit most, and what would it take to implement?</a:t>
             </a:r>
           </a:p>
         </p:txBody>
@@ -5092,7 +5687,7 @@
               <a:rPr lang="en-US" sz="1400" i="1" dirty="0">
                 <a:latin typeface="Abadi Extra Light" panose="020B0604020202020204" pitchFamily="34" charset="0"/>
               </a:rPr>
-              <a:t>Data sources: RTAMS (CTA Ridership; Rail Lines and Stations); City of Chicago Data Portal (CCVI).</a:t>
+              <a:t>Sources: Walker (2012), Human Transit; Litman, Victoria Transport Policy Institute.</a:t>
             </a:r>
             <a:endParaRPr lang="en-US" sz="1400" i="1" cap="none" dirty="0">
               <a:latin typeface="Abadi Extra Light" panose="020B0604020202020204" pitchFamily="34" charset="0"/>
@@ -5102,56 +5697,6 @@
       </p:sp>
       <p:sp>
         <p:nvSpPr>
-          <p:cNvPr id="3" name="Placeholder 1"/>
-          <p:cNvSpPr/>
-          <p:nvPr/>
-        </p:nvSpPr>
-        <p:spPr>
-          <a:xfrm>
-            <a:off x="6735536" y="1698171"/>
-            <a:ext cx="4302578" cy="3788229"/>
-          </a:xfrm>
-          <a:prstGeom prst="roundRect">
-            <a:avLst/>
-          </a:prstGeom>
-        </p:spPr>
-        <p:style>
-          <a:lnRef idx="2">
-            <a:schemeClr val="accent1">
-              <a:shade val="15000"/>
-            </a:schemeClr>
-          </a:lnRef>
-          <a:fillRef idx="1">
-            <a:schemeClr val="accent1"/>
-          </a:fillRef>
-          <a:effectRef idx="0">
-            <a:schemeClr val="accent1"/>
-          </a:effectRef>
-          <a:fontRef idx="minor">
-            <a:schemeClr val="lt1"/>
-          </a:fontRef>
-        </p:style>
-        <p:txBody>
-          <a:bodyPr rtlCol="0" anchor="ctr"/>
-          <a:lstStyle/>
-          <a:p>
-            <a:pPr algn="ctr"/>
-            <a:r>
-              <a:rPr lang="en-US" dirty="0"/>
-              <a:t>Insert custom station ridership change map (Figure 7)</a:t>
-            </a:r>
-            <a:br>
-              <a:rPr lang="en-US" dirty="0"/>
-            </a:br>
-            <a:r>
-              <a:rPr lang="en-US" dirty="0"/>
-              <a:t>created in step #5 of exercise.</a:t>
-            </a:r>
-          </a:p>
-        </p:txBody>
-      </p:sp>
-      <p:sp>
-        <p:nvSpPr>
           <p:cNvPr id="20" name="Footer Placeholder 19"/>
           <p:cNvSpPr>
             <a:spLocks noGrp="1"/>
@@ -5199,12 +5744,250 @@
           <a:p>
             <a:fld id="{C3DB2ADC-AF19-4574-8C10-79B5B04FCA27}" type="slidenum">
               <a:rPr lang="en-US" sz="1050"/>
-              <a:t>6</a:t>
+              <a:t>8</a:t>
             </a:fld>
             <a:endParaRPr lang="en-US" sz="1050"/>
           </a:p>
         </p:txBody>
       </p:sp>
+      <p:graphicFrame>
+        <p:nvGraphicFramePr>
+          <p:cNvPr id="22" name="Table 21"/>
+          <p:cNvGraphicFramePr>
+            <a:graphicFrameLocks noGrp="1"/>
+          </p:cNvGraphicFramePr>
+          <p:nvPr/>
+        </p:nvGraphicFramePr>
+        <p:xfrm>
+          <a:off x="6535536" y="1698171"/>
+          <a:ext cx="4700000" cy="3788229"/>
+        </p:xfrm>
+        <a:graphic>
+          <a:graphicData uri="http://schemas.openxmlformats.org/drawingml/2006/table">
+            <a:tbl>
+              <a:tblPr firstRow="1" bandRow="1">
+                <a:tableStyleId>{5C22544A-7EE6-4342-B048-85BDC9FD1C3A}</a:tableStyleId>
+              </a:tblPr>
+              <a:tblGrid>
+                <a:gridCol w="1050000"/>
+                <a:gridCol w="1200000"/>
+                <a:gridCol w="1200000"/>
+                <a:gridCol w="1250000"/>
+              </a:tblGrid>
+              <a:tr h="757645">
+                <a:tc>
+                  <a:txBody>
+                    <a:bodyPr/>
+                    <a:lstStyle/>
+                    <a:p>
+                      <a:r>
+                        <a:rPr sz="1100" b="1"/>
+                        <a:t>Community Area</a:t>
+                      </a:r>
+                    </a:p>
+                  </a:txBody>
+                  <a:tcPr marL="60000" marR="60000"/>
+                </a:tc>
+                <a:tc>
+                  <a:txBody>
+                    <a:bodyPr/>
+                    <a:lstStyle/>
+                    <a:p>
+                      <a:r>
+                        <a:rPr sz="1100" b="1"/>
+                        <a:t>Barrier (demand or trip phase)</a:t>
+                      </a:r>
+                    </a:p>
+                  </a:txBody>
+                  <a:tcPr marL="60000" marR="60000"/>
+                </a:tc>
+                <a:tc>
+                  <a:txBody>
+                    <a:bodyPr/>
+                    <a:lstStyle/>
+                    <a:p>
+                      <a:r>
+                        <a:rPr sz="1100" b="1"/>
+                        <a:t>Proposed Strategy</a:t>
+                      </a:r>
+                    </a:p>
+                  </a:txBody>
+                  <a:tcPr marL="60000" marR="60000"/>
+                </a:tc>
+                <a:tc>
+                  <a:txBody>
+                    <a:bodyPr/>
+                    <a:lstStyle/>
+                    <a:p>
+                      <a:r>
+                        <a:rPr sz="1100" b="1"/>
+                        <a:t>Expected Effect and Tradeoffs</a:t>
+                      </a:r>
+                    </a:p>
+                  </a:txBody>
+                  <a:tcPr marL="60000" marR="60000"/>
+                </a:tc>
+              </a:tr>
+              <a:tr h="757645">
+                <a:tc>
+                  <a:txBody>
+                    <a:bodyPr/>
+                    <a:lstStyle/>
+                    <a:p>
+                      <a:r>
+                        <a:rPr sz="1050" b="1"/>
+                        <a:t>[Focus area 1]</a:t>
+                      </a:r>
+                    </a:p>
+                  </a:txBody>
+                  <a:tcPr marL="60000" marR="60000"/>
+                </a:tc>
+                <a:tc>
+                  <a:txBody>
+                    <a:bodyPr/>
+                    <a:lstStyle/>
+                    <a:p/>
+                  </a:txBody>
+                  <a:tcPr marL="60000" marR="60000"/>
+                </a:tc>
+                <a:tc>
+                  <a:txBody>
+                    <a:bodyPr/>
+                    <a:lstStyle/>
+                    <a:p/>
+                  </a:txBody>
+                  <a:tcPr marL="60000" marR="60000"/>
+                </a:tc>
+                <a:tc>
+                  <a:txBody>
+                    <a:bodyPr/>
+                    <a:lstStyle/>
+                    <a:p/>
+                  </a:txBody>
+                  <a:tcPr marL="60000" marR="60000"/>
+                </a:tc>
+              </a:tr>
+              <a:tr h="757645">
+                <a:tc>
+                  <a:txBody>
+                    <a:bodyPr/>
+                    <a:lstStyle/>
+                    <a:p>
+                      <a:r>
+                        <a:rPr sz="1050" b="1"/>
+                        <a:t>[Focus area 2]</a:t>
+                      </a:r>
+                    </a:p>
+                  </a:txBody>
+                  <a:tcPr marL="60000" marR="60000"/>
+                </a:tc>
+                <a:tc>
+                  <a:txBody>
+                    <a:bodyPr/>
+                    <a:lstStyle/>
+                    <a:p/>
+                  </a:txBody>
+                  <a:tcPr marL="60000" marR="60000"/>
+                </a:tc>
+                <a:tc>
+                  <a:txBody>
+                    <a:bodyPr/>
+                    <a:lstStyle/>
+                    <a:p/>
+                  </a:txBody>
+                  <a:tcPr marL="60000" marR="60000"/>
+                </a:tc>
+                <a:tc>
+                  <a:txBody>
+                    <a:bodyPr/>
+                    <a:lstStyle/>
+                    <a:p/>
+                  </a:txBody>
+                  <a:tcPr marL="60000" marR="60000"/>
+                </a:tc>
+              </a:tr>
+              <a:tr h="757645">
+                <a:tc>
+                  <a:txBody>
+                    <a:bodyPr/>
+                    <a:lstStyle/>
+                    <a:p>
+                      <a:r>
+                        <a:rPr sz="1050" b="1"/>
+                        <a:t>[Focus area 3]</a:t>
+                      </a:r>
+                    </a:p>
+                  </a:txBody>
+                  <a:tcPr marL="60000" marR="60000"/>
+                </a:tc>
+                <a:tc>
+                  <a:txBody>
+                    <a:bodyPr/>
+                    <a:lstStyle/>
+                    <a:p/>
+                  </a:txBody>
+                  <a:tcPr marL="60000" marR="60000"/>
+                </a:tc>
+                <a:tc>
+                  <a:txBody>
+                    <a:bodyPr/>
+                    <a:lstStyle/>
+                    <a:p/>
+                  </a:txBody>
+                  <a:tcPr marL="60000" marR="60000"/>
+                </a:tc>
+                <a:tc>
+                  <a:txBody>
+                    <a:bodyPr/>
+                    <a:lstStyle/>
+                    <a:p/>
+                  </a:txBody>
+                  <a:tcPr marL="60000" marR="60000"/>
+                </a:tc>
+              </a:tr>
+              <a:tr h="757649">
+                <a:tc>
+                  <a:txBody>
+                    <a:bodyPr/>
+                    <a:lstStyle/>
+                    <a:p>
+                      <a:r>
+                        <a:rPr sz="1050" b="1"/>
+                        <a:t>Citywide</a:t>
+                      </a:r>
+                    </a:p>
+                  </a:txBody>
+                  <a:tcPr marL="60000" marR="60000"/>
+                </a:tc>
+                <a:tc>
+                  <a:txBody>
+                    <a:bodyPr/>
+                    <a:lstStyle/>
+                    <a:p/>
+                  </a:txBody>
+                  <a:tcPr marL="60000" marR="60000"/>
+                </a:tc>
+                <a:tc>
+                  <a:txBody>
+                    <a:bodyPr/>
+                    <a:lstStyle/>
+                    <a:p/>
+                  </a:txBody>
+                  <a:tcPr marL="60000" marR="60000"/>
+                </a:tc>
+                <a:tc>
+                  <a:txBody>
+                    <a:bodyPr/>
+                    <a:lstStyle/>
+                    <a:p/>
+                  </a:txBody>
+                  <a:tcPr marL="60000" marR="60000"/>
+                </a:tc>
+              </a:tr>
+            </a:tbl>
+          </a:graphicData>
+        </a:graphic>
+      </p:graphicFrame>
     </p:spTree>
     <p:extLst>
       <p:ext uri="{BB962C8B-B14F-4D97-AF65-F5344CB8AC3E}">

</xml_diff>